<commit_message>
Replace placeholder graphics with real illustrations across HTML and PPTX
Since the original factory presentation wasn't provided (only the
letterhead), added honest illustrative graphics instead of leaving
"insert real photo here" placeholders:
- Slide 5: own vector schematics of the RH570 (wireless) and RH2000
  (wired) sensor -> gateway -> server architecture
- Slide 7: a labeled illustrative bar chart (clearly marked as
  reference data pending real case numbers), matching "keep only the
  graph" from the source deck's slide 29
- Slide 6: a small certification badge icon

PPTX versions use native shapes/connectors rather than a chart object
or embedded images, matching the HTML's inline-SVG approach.
</commit_message>
<xml_diff>
--- a/presentations/algoritm/algoritm-predictive-maintenance-Swiss.pptx
+++ b/presentations/algoritm/algoritm-predictive-maintenance-Swiss.pptx
@@ -6273,19 +6273,17 @@
         </p:nvSpPr>
         <p:spPr>
           <a:xfrm>
-            <a:off x="868680" y="3063240"/>
-            <a:ext cx="4846320" cy="1051560"/>
+            <a:off x="868680" y="3017520"/>
+            <a:ext cx="4846320" cy="1097280"/>
           </a:xfrm>
           <a:prstGeom prst="rect">
             <a:avLst/>
           </a:prstGeom>
           <a:solidFill>
-            <a:srgbClr val="F6E3E1"/>
+            <a:srgbClr val="F1EFEE"/>
           </a:solidFill>
-          <a:ln w="9525">
-            <a:solidFill>
-              <a:srgbClr val="B72E26"/>
-            </a:solidFill>
+          <a:ln>
+            <a:noFill/>
           </a:ln>
           <a:effectLst/>
         </p:spPr>
@@ -6304,111 +6302,136 @@
           </a:fontRef>
         </p:style>
         <p:txBody>
-          <a:bodyPr rtlCol="0" anchor="ctr" wrap="square" lIns="137160" rIns="137160"/>
-          <a:lstStyle/>
-          <a:p>
-            <a:pPr algn="ctr">
-              <a:lnSpc>
-                <a:spcPct val="120000"/>
-              </a:lnSpc>
-              <a:spcBef>
-                <a:spcPts val="0"/>
-              </a:spcBef>
-              <a:spcAft>
-                <a:spcPts val="0"/>
-              </a:spcAft>
-            </a:pPr>
-            <a:r>
-              <a:rPr sz="1050" b="1">
-                <a:solidFill>
-                  <a:srgbClr val="8C1B13"/>
-                </a:solidFill>
-                <a:latin typeface="DM Sans"/>
-              </a:rPr>
-              <a:t>Схема из исходной презентации (слайды 12–14).</a:t>
-            </a:r>
-          </a:p>
-          <a:p>
-            <a:pPr algn="ctr">
-              <a:lnSpc>
-                <a:spcPct val="120000"/>
-              </a:lnSpc>
-              <a:spcBef>
-                <a:spcPts val="0"/>
-              </a:spcBef>
-              <a:spcAft>
-                <a:spcPts val="0"/>
-              </a:spcAft>
-            </a:pPr>
-            <a:r>
-              <a:rPr sz="1050" b="1">
-                <a:solidFill>
-                  <a:srgbClr val="8C1B13"/>
-                </a:solidFill>
-                <a:latin typeface="DM Sans"/>
-              </a:rPr>
-              <a:t>Логотипы завода-изготовителя на корпусах приборов удаляются.</a:t>
-            </a:r>
-          </a:p>
-        </p:txBody>
-      </p:sp>
-      <p:sp>
-        <p:nvSpPr>
-          <p:cNvPr id="11" name="TextBox 10"/>
-          <p:cNvSpPr txBox="1"/>
-          <p:nvPr/>
-        </p:nvSpPr>
-        <p:spPr>
-          <a:xfrm>
-            <a:off x="868680" y="4297680"/>
-            <a:ext cx="4846320" cy="640080"/>
-          </a:xfrm>
-          <a:prstGeom prst="rect">
-            <a:avLst/>
-          </a:prstGeom>
-          <a:noFill/>
-        </p:spPr>
-        <p:txBody>
-          <a:bodyPr wrap="square" anchor="t" lIns="0" rIns="0" tIns="0" bIns="0">
-            <a:spAutoFit/>
-          </a:bodyPr>
-          <a:lstStyle/>
-          <a:p>
-            <a:pPr algn="l">
-              <a:lnSpc>
-                <a:spcPct val="130000"/>
-              </a:lnSpc>
-              <a:spcBef>
-                <a:spcPts val="0"/>
-              </a:spcBef>
-              <a:spcAft>
-                <a:spcPts val="0"/>
-              </a:spcAft>
-            </a:pPr>
-            <a:r>
-              <a:rPr sz="1250" b="0">
-                <a:solidFill>
-                  <a:srgbClr val="5A5757"/>
-                </a:solidFill>
-                <a:latin typeface="DM Sans"/>
-              </a:rPr>
-              <a:t>Развёртывание без прокладки кабельных трасс — для распределённого и труднодоступного оборудования.</a:t>
-            </a:r>
-          </a:p>
-        </p:txBody>
-      </p:sp>
-      <p:sp>
-        <p:nvSpPr>
-          <p:cNvPr id="12" name="Rectangle 11"/>
+          <a:bodyPr rtlCol="0" anchor="ctr"/>
+          <a:lstStyle/>
+          <a:p>
+            <a:pPr algn="ctr"/>
+          </a:p>
+        </p:txBody>
+      </p:sp>
+      <p:cxnSp>
+        <p:nvCxnSpPr>
+          <p:cNvPr id="11" name="Connector 10"/>
+          <p:cNvCxnSpPr/>
+          <p:nvPr/>
+        </p:nvCxnSpPr>
+        <p:spPr>
+          <a:xfrm>
+            <a:off x="1193292" y="3291840"/>
+            <a:ext cx="589788" cy="274320"/>
+          </a:xfrm>
+          <a:prstGeom prst="line">
+            <a:avLst/>
+          </a:prstGeom>
+          <a:ln w="13970">
+            <a:solidFill>
+              <a:srgbClr val="B72E26"/>
+            </a:solidFill>
+            <a:prstDash val="dash"/>
+          </a:ln>
+          <a:effectLst/>
+        </p:spPr>
+        <p:style>
+          <a:lnRef idx="2">
+            <a:schemeClr val="accent1"/>
+          </a:lnRef>
+          <a:fillRef idx="0">
+            <a:schemeClr val="accent1"/>
+          </a:fillRef>
+          <a:effectRef idx="1">
+            <a:schemeClr val="accent1"/>
+          </a:effectRef>
+          <a:fontRef idx="minor">
+            <a:schemeClr val="tx1"/>
+          </a:fontRef>
+        </p:style>
+      </p:cxnSp>
+      <p:cxnSp>
+        <p:nvCxnSpPr>
+          <p:cNvPr id="12" name="Connector 11"/>
+          <p:cNvCxnSpPr/>
+          <p:nvPr/>
+        </p:nvCxnSpPr>
+        <p:spPr>
+          <a:xfrm>
+            <a:off x="1193292" y="3566160"/>
+            <a:ext cx="589788" cy="0"/>
+          </a:xfrm>
+          <a:prstGeom prst="line">
+            <a:avLst/>
+          </a:prstGeom>
+          <a:ln w="13970">
+            <a:solidFill>
+              <a:srgbClr val="B72E26"/>
+            </a:solidFill>
+            <a:prstDash val="dash"/>
+          </a:ln>
+          <a:effectLst/>
+        </p:spPr>
+        <p:style>
+          <a:lnRef idx="2">
+            <a:schemeClr val="accent1"/>
+          </a:lnRef>
+          <a:fillRef idx="0">
+            <a:schemeClr val="accent1"/>
+          </a:fillRef>
+          <a:effectRef idx="1">
+            <a:schemeClr val="accent1"/>
+          </a:effectRef>
+          <a:fontRef idx="minor">
+            <a:schemeClr val="tx1"/>
+          </a:fontRef>
+        </p:style>
+      </p:cxnSp>
+      <p:cxnSp>
+        <p:nvCxnSpPr>
+          <p:cNvPr id="13" name="Connector 12"/>
+          <p:cNvCxnSpPr/>
+          <p:nvPr/>
+        </p:nvCxnSpPr>
+        <p:spPr>
+          <a:xfrm flipV="1">
+            <a:off x="1193292" y="3566160"/>
+            <a:ext cx="589788" cy="274320"/>
+          </a:xfrm>
+          <a:prstGeom prst="line">
+            <a:avLst/>
+          </a:prstGeom>
+          <a:ln w="13970">
+            <a:solidFill>
+              <a:srgbClr val="B72E26"/>
+            </a:solidFill>
+            <a:prstDash val="dash"/>
+          </a:ln>
+          <a:effectLst/>
+        </p:spPr>
+        <p:style>
+          <a:lnRef idx="2">
+            <a:schemeClr val="accent1"/>
+          </a:lnRef>
+          <a:fillRef idx="0">
+            <a:schemeClr val="accent1"/>
+          </a:fillRef>
+          <a:effectRef idx="1">
+            <a:schemeClr val="accent1"/>
+          </a:effectRef>
+          <a:fontRef idx="minor">
+            <a:schemeClr val="tx1"/>
+          </a:fontRef>
+        </p:style>
+      </p:cxnSp>
+      <p:sp>
+        <p:nvSpPr>
+          <p:cNvPr id="14" name="Oval 13"/>
           <p:cNvSpPr/>
           <p:nvPr/>
         </p:nvSpPr>
         <p:spPr>
           <a:xfrm>
-            <a:off x="6172200" y="1965960"/>
-            <a:ext cx="5486400" cy="41148"/>
-          </a:xfrm>
-          <a:prstGeom prst="rect">
+            <a:off x="1124712" y="3223260"/>
+            <a:ext cx="137160" cy="137160"/>
+          </a:xfrm>
+          <a:prstGeom prst="ellipse">
             <a:avLst/>
           </a:prstGeom>
           <a:solidFill>
@@ -6443,7 +6466,552 @@
       </p:sp>
       <p:sp>
         <p:nvSpPr>
-          <p:cNvPr id="13" name="Rectangle 12"/>
+          <p:cNvPr id="15" name="Oval 14"/>
+          <p:cNvSpPr/>
+          <p:nvPr/>
+        </p:nvSpPr>
+        <p:spPr>
+          <a:xfrm>
+            <a:off x="1124712" y="3497580"/>
+            <a:ext cx="137160" cy="137160"/>
+          </a:xfrm>
+          <a:prstGeom prst="ellipse">
+            <a:avLst/>
+          </a:prstGeom>
+          <a:solidFill>
+            <a:srgbClr val="141212"/>
+          </a:solidFill>
+          <a:ln>
+            <a:noFill/>
+          </a:ln>
+          <a:effectLst/>
+        </p:spPr>
+        <p:style>
+          <a:lnRef idx="1">
+            <a:schemeClr val="accent1"/>
+          </a:lnRef>
+          <a:fillRef idx="3">
+            <a:schemeClr val="accent1"/>
+          </a:fillRef>
+          <a:effectRef idx="2">
+            <a:schemeClr val="accent1"/>
+          </a:effectRef>
+          <a:fontRef idx="minor">
+            <a:schemeClr val="lt1"/>
+          </a:fontRef>
+        </p:style>
+        <p:txBody>
+          <a:bodyPr rtlCol="0" anchor="ctr"/>
+          <a:lstStyle/>
+          <a:p>
+            <a:pPr algn="ctr"/>
+          </a:p>
+        </p:txBody>
+      </p:sp>
+      <p:sp>
+        <p:nvSpPr>
+          <p:cNvPr id="16" name="Oval 15"/>
+          <p:cNvSpPr/>
+          <p:nvPr/>
+        </p:nvSpPr>
+        <p:spPr>
+          <a:xfrm>
+            <a:off x="1124712" y="3771900"/>
+            <a:ext cx="137160" cy="137160"/>
+          </a:xfrm>
+          <a:prstGeom prst="ellipse">
+            <a:avLst/>
+          </a:prstGeom>
+          <a:solidFill>
+            <a:srgbClr val="141212"/>
+          </a:solidFill>
+          <a:ln>
+            <a:noFill/>
+          </a:ln>
+          <a:effectLst/>
+        </p:spPr>
+        <p:style>
+          <a:lnRef idx="1">
+            <a:schemeClr val="accent1"/>
+          </a:lnRef>
+          <a:fillRef idx="3">
+            <a:schemeClr val="accent1"/>
+          </a:fillRef>
+          <a:effectRef idx="2">
+            <a:schemeClr val="accent1"/>
+          </a:effectRef>
+          <a:fontRef idx="minor">
+            <a:schemeClr val="lt1"/>
+          </a:fontRef>
+        </p:style>
+        <p:txBody>
+          <a:bodyPr rtlCol="0" anchor="ctr"/>
+          <a:lstStyle/>
+          <a:p>
+            <a:pPr algn="ctr"/>
+          </a:p>
+        </p:txBody>
+      </p:sp>
+      <p:sp>
+        <p:nvSpPr>
+          <p:cNvPr id="17" name="TextBox 16"/>
+          <p:cNvSpPr txBox="1"/>
+          <p:nvPr/>
+        </p:nvSpPr>
+        <p:spPr>
+          <a:xfrm>
+            <a:off x="804672" y="3959352"/>
+            <a:ext cx="914400" cy="182880"/>
+          </a:xfrm>
+          <a:prstGeom prst="rect">
+            <a:avLst/>
+          </a:prstGeom>
+          <a:noFill/>
+        </p:spPr>
+        <p:txBody>
+          <a:bodyPr wrap="square" anchor="t" lIns="0" rIns="0" tIns="0" bIns="0">
+            <a:spAutoFit/>
+          </a:bodyPr>
+          <a:lstStyle/>
+          <a:p>
+            <a:pPr algn="ctr">
+              <a:lnSpc>
+                <a:spcPct val="100000"/>
+              </a:lnSpc>
+              <a:spcBef>
+                <a:spcPts val="0"/>
+              </a:spcBef>
+              <a:spcAft>
+                <a:spcPts val="0"/>
+              </a:spcAft>
+            </a:pPr>
+            <a:r>
+              <a:rPr sz="650" b="0">
+                <a:solidFill>
+                  <a:srgbClr val="5A5757"/>
+                </a:solidFill>
+                <a:latin typeface="DM Sans"/>
+              </a:rPr>
+              <a:t>Датчики</a:t>
+            </a:r>
+          </a:p>
+        </p:txBody>
+      </p:sp>
+      <p:sp>
+        <p:nvSpPr>
+          <p:cNvPr id="18" name="TextBox 17"/>
+          <p:cNvSpPr txBox="1"/>
+          <p:nvPr/>
+        </p:nvSpPr>
+        <p:spPr>
+          <a:xfrm>
+            <a:off x="1600200" y="3163824"/>
+            <a:ext cx="1417320" cy="164592"/>
+          </a:xfrm>
+          <a:prstGeom prst="rect">
+            <a:avLst/>
+          </a:prstGeom>
+          <a:noFill/>
+        </p:spPr>
+        <p:txBody>
+          <a:bodyPr wrap="square" anchor="t" lIns="0" rIns="0" tIns="0" bIns="0">
+            <a:spAutoFit/>
+          </a:bodyPr>
+          <a:lstStyle/>
+          <a:p>
+            <a:pPr algn="ctr">
+              <a:lnSpc>
+                <a:spcPct val="100000"/>
+              </a:lnSpc>
+              <a:spcBef>
+                <a:spcPts val="0"/>
+              </a:spcBef>
+              <a:spcAft>
+                <a:spcPts val="0"/>
+              </a:spcAft>
+            </a:pPr>
+            <a:r>
+              <a:rPr sz="600" b="0">
+                <a:solidFill>
+                  <a:srgbClr val="5A5757"/>
+                </a:solidFill>
+                <a:latin typeface="DM Sans"/>
+              </a:rPr>
+              <a:t>LoRaWAN · Wi-Fi</a:t>
+            </a:r>
+          </a:p>
+        </p:txBody>
+      </p:sp>
+      <p:sp>
+        <p:nvSpPr>
+          <p:cNvPr id="19" name="Rounded Rectangle 18"/>
+          <p:cNvSpPr/>
+          <p:nvPr/>
+        </p:nvSpPr>
+        <p:spPr>
+          <a:xfrm>
+            <a:off x="1783080" y="3346704"/>
+            <a:ext cx="1051560" cy="438912"/>
+          </a:xfrm>
+          <a:prstGeom prst="roundRect">
+            <a:avLst>
+              <a:gd name="adj" fmla="val 18000"/>
+            </a:avLst>
+          </a:prstGeom>
+          <a:solidFill>
+            <a:srgbClr val="B72E26"/>
+          </a:solidFill>
+          <a:ln>
+            <a:noFill/>
+          </a:ln>
+          <a:effectLst/>
+        </p:spPr>
+        <p:style>
+          <a:lnRef idx="1">
+            <a:schemeClr val="accent1"/>
+          </a:lnRef>
+          <a:fillRef idx="3">
+            <a:schemeClr val="accent1"/>
+          </a:fillRef>
+          <a:effectRef idx="2">
+            <a:schemeClr val="accent1"/>
+          </a:effectRef>
+          <a:fontRef idx="minor">
+            <a:schemeClr val="lt1"/>
+          </a:fontRef>
+        </p:style>
+        <p:txBody>
+          <a:bodyPr rtlCol="0" anchor="ctr" wrap="square" lIns="36576" rIns="36576"/>
+          <a:lstStyle/>
+          <a:p>
+            <a:pPr algn="ctr">
+              <a:lnSpc>
+                <a:spcPct val="105000"/>
+              </a:lnSpc>
+              <a:spcBef>
+                <a:spcPts val="0"/>
+              </a:spcBef>
+              <a:spcAft>
+                <a:spcPts val="0"/>
+              </a:spcAft>
+            </a:pPr>
+            <a:r>
+              <a:rPr sz="1050" b="1">
+                <a:solidFill>
+                  <a:srgbClr val="FFFFFF"/>
+                </a:solidFill>
+                <a:latin typeface="DM Sans"/>
+              </a:rPr>
+              <a:t>RH570</a:t>
+            </a:r>
+          </a:p>
+        </p:txBody>
+      </p:sp>
+      <p:sp>
+        <p:nvSpPr>
+          <p:cNvPr id="20" name="TextBox 19"/>
+          <p:cNvSpPr txBox="1"/>
+          <p:nvPr/>
+        </p:nvSpPr>
+        <p:spPr>
+          <a:xfrm>
+            <a:off x="1600200" y="3803904"/>
+            <a:ext cx="1417320" cy="164592"/>
+          </a:xfrm>
+          <a:prstGeom prst="rect">
+            <a:avLst/>
+          </a:prstGeom>
+          <a:noFill/>
+        </p:spPr>
+        <p:txBody>
+          <a:bodyPr wrap="square" anchor="t" lIns="0" rIns="0" tIns="0" bIns="0">
+            <a:spAutoFit/>
+          </a:bodyPr>
+          <a:lstStyle/>
+          <a:p>
+            <a:pPr algn="ctr">
+              <a:lnSpc>
+                <a:spcPct val="100000"/>
+              </a:lnSpc>
+              <a:spcBef>
+                <a:spcPts val="0"/>
+              </a:spcBef>
+              <a:spcAft>
+                <a:spcPts val="0"/>
+              </a:spcAft>
+            </a:pPr>
+            <a:r>
+              <a:rPr sz="600" b="0">
+                <a:solidFill>
+                  <a:srgbClr val="5A5757"/>
+                </a:solidFill>
+                <a:latin typeface="DM Sans"/>
+              </a:rPr>
+              <a:t>Шлюз</a:t>
+            </a:r>
+          </a:p>
+        </p:txBody>
+      </p:sp>
+      <p:cxnSp>
+        <p:nvCxnSpPr>
+          <p:cNvPr id="21" name="Connector 20"/>
+          <p:cNvCxnSpPr/>
+          <p:nvPr/>
+        </p:nvCxnSpPr>
+        <p:spPr>
+          <a:xfrm>
+            <a:off x="2834640" y="3566160"/>
+            <a:ext cx="1691640" cy="0"/>
+          </a:xfrm>
+          <a:prstGeom prst="line">
+            <a:avLst/>
+          </a:prstGeom>
+          <a:ln w="13970">
+            <a:solidFill>
+              <a:srgbClr val="141212"/>
+            </a:solidFill>
+          </a:ln>
+          <a:effectLst/>
+        </p:spPr>
+        <p:style>
+          <a:lnRef idx="2">
+            <a:schemeClr val="accent1"/>
+          </a:lnRef>
+          <a:fillRef idx="0">
+            <a:schemeClr val="accent1"/>
+          </a:fillRef>
+          <a:effectRef idx="1">
+            <a:schemeClr val="accent1"/>
+          </a:effectRef>
+          <a:fontRef idx="minor">
+            <a:schemeClr val="tx1"/>
+          </a:fontRef>
+        </p:style>
+      </p:cxnSp>
+      <p:sp>
+        <p:nvSpPr>
+          <p:cNvPr id="22" name="Rounded Rectangle 21"/>
+          <p:cNvSpPr/>
+          <p:nvPr/>
+        </p:nvSpPr>
+        <p:spPr>
+          <a:xfrm>
+            <a:off x="4526280" y="3346704"/>
+            <a:ext cx="1051560" cy="438912"/>
+          </a:xfrm>
+          <a:prstGeom prst="roundRect">
+            <a:avLst>
+              <a:gd name="adj" fmla="val 18000"/>
+            </a:avLst>
+          </a:prstGeom>
+          <a:solidFill>
+            <a:srgbClr val="141212"/>
+          </a:solidFill>
+          <a:ln>
+            <a:noFill/>
+          </a:ln>
+          <a:effectLst/>
+        </p:spPr>
+        <p:style>
+          <a:lnRef idx="1">
+            <a:schemeClr val="accent1"/>
+          </a:lnRef>
+          <a:fillRef idx="3">
+            <a:schemeClr val="accent1"/>
+          </a:fillRef>
+          <a:effectRef idx="2">
+            <a:schemeClr val="accent1"/>
+          </a:effectRef>
+          <a:fontRef idx="minor">
+            <a:schemeClr val="lt1"/>
+          </a:fontRef>
+        </p:style>
+        <p:txBody>
+          <a:bodyPr rtlCol="0" anchor="ctr" wrap="square" lIns="36576" rIns="36576"/>
+          <a:lstStyle/>
+          <a:p>
+            <a:pPr algn="ctr">
+              <a:lnSpc>
+                <a:spcPct val="105000"/>
+              </a:lnSpc>
+              <a:spcBef>
+                <a:spcPts val="0"/>
+              </a:spcBef>
+              <a:spcAft>
+                <a:spcPts val="0"/>
+              </a:spcAft>
+            </a:pPr>
+            <a:r>
+              <a:rPr sz="850" b="1">
+                <a:solidFill>
+                  <a:srgbClr val="FFFFFF"/>
+                </a:solidFill>
+                <a:latin typeface="DM Sans"/>
+              </a:rPr>
+              <a:t>СЕРВЕР</a:t>
+            </a:r>
+          </a:p>
+          <a:p>
+            <a:pPr algn="ctr">
+              <a:lnSpc>
+                <a:spcPct val="105000"/>
+              </a:lnSpc>
+              <a:spcBef>
+                <a:spcPts val="0"/>
+              </a:spcBef>
+              <a:spcAft>
+                <a:spcPts val="0"/>
+              </a:spcAft>
+            </a:pPr>
+            <a:r>
+              <a:rPr sz="850" b="1">
+                <a:solidFill>
+                  <a:srgbClr val="FFFFFF"/>
+                </a:solidFill>
+                <a:latin typeface="DM Sans"/>
+              </a:rPr>
+              <a:t>АСУ ТП</a:t>
+            </a:r>
+          </a:p>
+        </p:txBody>
+      </p:sp>
+      <p:sp>
+        <p:nvSpPr>
+          <p:cNvPr id="23" name="TextBox 22"/>
+          <p:cNvSpPr txBox="1"/>
+          <p:nvPr/>
+        </p:nvSpPr>
+        <p:spPr>
+          <a:xfrm>
+            <a:off x="4251960" y="3803904"/>
+            <a:ext cx="1600200" cy="164592"/>
+          </a:xfrm>
+          <a:prstGeom prst="rect">
+            <a:avLst/>
+          </a:prstGeom>
+          <a:noFill/>
+        </p:spPr>
+        <p:txBody>
+          <a:bodyPr wrap="square" anchor="t" lIns="0" rIns="0" tIns="0" bIns="0">
+            <a:spAutoFit/>
+          </a:bodyPr>
+          <a:lstStyle/>
+          <a:p>
+            <a:pPr algn="ctr">
+              <a:lnSpc>
+                <a:spcPct val="100000"/>
+              </a:lnSpc>
+              <a:spcBef>
+                <a:spcPts val="0"/>
+              </a:spcBef>
+              <a:spcAft>
+                <a:spcPts val="0"/>
+              </a:spcAft>
+            </a:pPr>
+            <a:r>
+              <a:rPr sz="600" b="0">
+                <a:solidFill>
+                  <a:srgbClr val="5A5757"/>
+                </a:solidFill>
+                <a:latin typeface="DM Sans"/>
+              </a:rPr>
+              <a:t>Хранение и анализ</a:t>
+            </a:r>
+          </a:p>
+        </p:txBody>
+      </p:sp>
+      <p:sp>
+        <p:nvSpPr>
+          <p:cNvPr id="24" name="TextBox 23"/>
+          <p:cNvSpPr txBox="1"/>
+          <p:nvPr/>
+        </p:nvSpPr>
+        <p:spPr>
+          <a:xfrm>
+            <a:off x="868680" y="4160520"/>
+            <a:ext cx="4846320" cy="384048"/>
+          </a:xfrm>
+          <a:prstGeom prst="rect">
+            <a:avLst/>
+          </a:prstGeom>
+          <a:noFill/>
+        </p:spPr>
+        <p:txBody>
+          <a:bodyPr wrap="square" anchor="t" lIns="0" rIns="0" tIns="0" bIns="0">
+            <a:spAutoFit/>
+          </a:bodyPr>
+          <a:lstStyle/>
+          <a:p>
+            <a:pPr algn="l">
+              <a:lnSpc>
+                <a:spcPct val="125000"/>
+              </a:lnSpc>
+              <a:spcBef>
+                <a:spcPts val="0"/>
+              </a:spcBef>
+              <a:spcAft>
+                <a:spcPts val="0"/>
+              </a:spcAft>
+            </a:pPr>
+            <a:r>
+              <a:rPr sz="1200" b="0">
+                <a:solidFill>
+                  <a:srgbClr val="5A5757"/>
+                </a:solidFill>
+                <a:latin typeface="DM Sans"/>
+              </a:rPr>
+              <a:t>Развёртывание без прокладки кабельных трасс — для распределённого и труднодоступного оборудования.</a:t>
+            </a:r>
+          </a:p>
+        </p:txBody>
+      </p:sp>
+      <p:sp>
+        <p:nvSpPr>
+          <p:cNvPr id="25" name="Rectangle 24"/>
+          <p:cNvSpPr/>
+          <p:nvPr/>
+        </p:nvSpPr>
+        <p:spPr>
+          <a:xfrm>
+            <a:off x="6172200" y="1965960"/>
+            <a:ext cx="5486400" cy="41148"/>
+          </a:xfrm>
+          <a:prstGeom prst="rect">
+            <a:avLst/>
+          </a:prstGeom>
+          <a:solidFill>
+            <a:srgbClr val="141212"/>
+          </a:solidFill>
+          <a:ln>
+            <a:noFill/>
+          </a:ln>
+          <a:effectLst/>
+        </p:spPr>
+        <p:style>
+          <a:lnRef idx="1">
+            <a:schemeClr val="accent1"/>
+          </a:lnRef>
+          <a:fillRef idx="3">
+            <a:schemeClr val="accent1"/>
+          </a:fillRef>
+          <a:effectRef idx="2">
+            <a:schemeClr val="accent1"/>
+          </a:effectRef>
+          <a:fontRef idx="minor">
+            <a:schemeClr val="lt1"/>
+          </a:fontRef>
+        </p:style>
+        <p:txBody>
+          <a:bodyPr rtlCol="0" anchor="ctr"/>
+          <a:lstStyle/>
+          <a:p>
+            <a:pPr algn="ctr"/>
+          </a:p>
+        </p:txBody>
+      </p:sp>
+      <p:sp>
+        <p:nvSpPr>
+          <p:cNvPr id="26" name="Rectangle 25"/>
           <p:cNvSpPr/>
           <p:nvPr/>
         </p:nvSpPr>
@@ -6487,7 +7055,7 @@
       </p:sp>
       <p:sp>
         <p:nvSpPr>
-          <p:cNvPr id="14" name="TextBox 13"/>
+          <p:cNvPr id="27" name="TextBox 26"/>
           <p:cNvSpPr txBox="1"/>
           <p:nvPr/>
         </p:nvSpPr>
@@ -6532,7 +7100,7 @@
       </p:sp>
       <p:sp>
         <p:nvSpPr>
-          <p:cNvPr id="15" name="TextBox 14"/>
+          <p:cNvPr id="28" name="TextBox 27"/>
           <p:cNvSpPr txBox="1"/>
           <p:nvPr/>
         </p:nvSpPr>
@@ -6577,22 +7145,503 @@
       </p:sp>
       <p:sp>
         <p:nvSpPr>
-          <p:cNvPr id="16" name="Rectangle 15"/>
+          <p:cNvPr id="29" name="Rectangle 28"/>
           <p:cNvSpPr/>
           <p:nvPr/>
         </p:nvSpPr>
         <p:spPr>
           <a:xfrm>
-            <a:off x="6492240" y="3063240"/>
-            <a:ext cx="4846320" cy="1051560"/>
+            <a:off x="6492240" y="3017520"/>
+            <a:ext cx="4846320" cy="1097280"/>
           </a:xfrm>
           <a:prstGeom prst="rect">
             <a:avLst/>
           </a:prstGeom>
           <a:solidFill>
-            <a:srgbClr val="F6E3E1"/>
+            <a:srgbClr val="F1EFEE"/>
           </a:solidFill>
-          <a:ln w="9525">
+          <a:ln>
+            <a:noFill/>
+          </a:ln>
+          <a:effectLst/>
+        </p:spPr>
+        <p:style>
+          <a:lnRef idx="1">
+            <a:schemeClr val="accent1"/>
+          </a:lnRef>
+          <a:fillRef idx="3">
+            <a:schemeClr val="accent1"/>
+          </a:fillRef>
+          <a:effectRef idx="2">
+            <a:schemeClr val="accent1"/>
+          </a:effectRef>
+          <a:fontRef idx="minor">
+            <a:schemeClr val="lt1"/>
+          </a:fontRef>
+        </p:style>
+        <p:txBody>
+          <a:bodyPr rtlCol="0" anchor="ctr"/>
+          <a:lstStyle/>
+          <a:p>
+            <a:pPr algn="ctr"/>
+          </a:p>
+        </p:txBody>
+      </p:sp>
+      <p:cxnSp>
+        <p:nvCxnSpPr>
+          <p:cNvPr id="30" name="Connector 29"/>
+          <p:cNvCxnSpPr/>
+          <p:nvPr/>
+        </p:nvCxnSpPr>
+        <p:spPr>
+          <a:xfrm>
+            <a:off x="6816852" y="3291840"/>
+            <a:ext cx="589788" cy="274320"/>
+          </a:xfrm>
+          <a:prstGeom prst="line">
+            <a:avLst/>
+          </a:prstGeom>
+          <a:ln w="13970">
+            <a:solidFill>
+              <a:srgbClr val="6E6A69"/>
+            </a:solidFill>
+          </a:ln>
+          <a:effectLst/>
+        </p:spPr>
+        <p:style>
+          <a:lnRef idx="2">
+            <a:schemeClr val="accent1"/>
+          </a:lnRef>
+          <a:fillRef idx="0">
+            <a:schemeClr val="accent1"/>
+          </a:fillRef>
+          <a:effectRef idx="1">
+            <a:schemeClr val="accent1"/>
+          </a:effectRef>
+          <a:fontRef idx="minor">
+            <a:schemeClr val="tx1"/>
+          </a:fontRef>
+        </p:style>
+      </p:cxnSp>
+      <p:cxnSp>
+        <p:nvCxnSpPr>
+          <p:cNvPr id="31" name="Connector 30"/>
+          <p:cNvCxnSpPr/>
+          <p:nvPr/>
+        </p:nvCxnSpPr>
+        <p:spPr>
+          <a:xfrm>
+            <a:off x="6816852" y="3566160"/>
+            <a:ext cx="589788" cy="0"/>
+          </a:xfrm>
+          <a:prstGeom prst="line">
+            <a:avLst/>
+          </a:prstGeom>
+          <a:ln w="13970">
+            <a:solidFill>
+              <a:srgbClr val="6E6A69"/>
+            </a:solidFill>
+          </a:ln>
+          <a:effectLst/>
+        </p:spPr>
+        <p:style>
+          <a:lnRef idx="2">
+            <a:schemeClr val="accent1"/>
+          </a:lnRef>
+          <a:fillRef idx="0">
+            <a:schemeClr val="accent1"/>
+          </a:fillRef>
+          <a:effectRef idx="1">
+            <a:schemeClr val="accent1"/>
+          </a:effectRef>
+          <a:fontRef idx="minor">
+            <a:schemeClr val="tx1"/>
+          </a:fontRef>
+        </p:style>
+      </p:cxnSp>
+      <p:cxnSp>
+        <p:nvCxnSpPr>
+          <p:cNvPr id="32" name="Connector 31"/>
+          <p:cNvCxnSpPr/>
+          <p:nvPr/>
+        </p:nvCxnSpPr>
+        <p:spPr>
+          <a:xfrm flipV="1">
+            <a:off x="6816852" y="3566160"/>
+            <a:ext cx="589788" cy="274320"/>
+          </a:xfrm>
+          <a:prstGeom prst="line">
+            <a:avLst/>
+          </a:prstGeom>
+          <a:ln w="13970">
+            <a:solidFill>
+              <a:srgbClr val="6E6A69"/>
+            </a:solidFill>
+          </a:ln>
+          <a:effectLst/>
+        </p:spPr>
+        <p:style>
+          <a:lnRef idx="2">
+            <a:schemeClr val="accent1"/>
+          </a:lnRef>
+          <a:fillRef idx="0">
+            <a:schemeClr val="accent1"/>
+          </a:fillRef>
+          <a:effectRef idx="1">
+            <a:schemeClr val="accent1"/>
+          </a:effectRef>
+          <a:fontRef idx="minor">
+            <a:schemeClr val="tx1"/>
+          </a:fontRef>
+        </p:style>
+      </p:cxnSp>
+      <p:sp>
+        <p:nvSpPr>
+          <p:cNvPr id="33" name="Oval 32"/>
+          <p:cNvSpPr/>
+          <p:nvPr/>
+        </p:nvSpPr>
+        <p:spPr>
+          <a:xfrm>
+            <a:off x="6748272" y="3223260"/>
+            <a:ext cx="137160" cy="137160"/>
+          </a:xfrm>
+          <a:prstGeom prst="ellipse">
+            <a:avLst/>
+          </a:prstGeom>
+          <a:solidFill>
+            <a:srgbClr val="141212"/>
+          </a:solidFill>
+          <a:ln>
+            <a:noFill/>
+          </a:ln>
+          <a:effectLst/>
+        </p:spPr>
+        <p:style>
+          <a:lnRef idx="1">
+            <a:schemeClr val="accent1"/>
+          </a:lnRef>
+          <a:fillRef idx="3">
+            <a:schemeClr val="accent1"/>
+          </a:fillRef>
+          <a:effectRef idx="2">
+            <a:schemeClr val="accent1"/>
+          </a:effectRef>
+          <a:fontRef idx="minor">
+            <a:schemeClr val="lt1"/>
+          </a:fontRef>
+        </p:style>
+        <p:txBody>
+          <a:bodyPr rtlCol="0" anchor="ctr"/>
+          <a:lstStyle/>
+          <a:p>
+            <a:pPr algn="ctr"/>
+          </a:p>
+        </p:txBody>
+      </p:sp>
+      <p:sp>
+        <p:nvSpPr>
+          <p:cNvPr id="34" name="Oval 33"/>
+          <p:cNvSpPr/>
+          <p:nvPr/>
+        </p:nvSpPr>
+        <p:spPr>
+          <a:xfrm>
+            <a:off x="6748272" y="3497580"/>
+            <a:ext cx="137160" cy="137160"/>
+          </a:xfrm>
+          <a:prstGeom prst="ellipse">
+            <a:avLst/>
+          </a:prstGeom>
+          <a:solidFill>
+            <a:srgbClr val="141212"/>
+          </a:solidFill>
+          <a:ln>
+            <a:noFill/>
+          </a:ln>
+          <a:effectLst/>
+        </p:spPr>
+        <p:style>
+          <a:lnRef idx="1">
+            <a:schemeClr val="accent1"/>
+          </a:lnRef>
+          <a:fillRef idx="3">
+            <a:schemeClr val="accent1"/>
+          </a:fillRef>
+          <a:effectRef idx="2">
+            <a:schemeClr val="accent1"/>
+          </a:effectRef>
+          <a:fontRef idx="minor">
+            <a:schemeClr val="lt1"/>
+          </a:fontRef>
+        </p:style>
+        <p:txBody>
+          <a:bodyPr rtlCol="0" anchor="ctr"/>
+          <a:lstStyle/>
+          <a:p>
+            <a:pPr algn="ctr"/>
+          </a:p>
+        </p:txBody>
+      </p:sp>
+      <p:sp>
+        <p:nvSpPr>
+          <p:cNvPr id="35" name="Oval 34"/>
+          <p:cNvSpPr/>
+          <p:nvPr/>
+        </p:nvSpPr>
+        <p:spPr>
+          <a:xfrm>
+            <a:off x="6748272" y="3771900"/>
+            <a:ext cx="137160" cy="137160"/>
+          </a:xfrm>
+          <a:prstGeom prst="ellipse">
+            <a:avLst/>
+          </a:prstGeom>
+          <a:solidFill>
+            <a:srgbClr val="141212"/>
+          </a:solidFill>
+          <a:ln>
+            <a:noFill/>
+          </a:ln>
+          <a:effectLst/>
+        </p:spPr>
+        <p:style>
+          <a:lnRef idx="1">
+            <a:schemeClr val="accent1"/>
+          </a:lnRef>
+          <a:fillRef idx="3">
+            <a:schemeClr val="accent1"/>
+          </a:fillRef>
+          <a:effectRef idx="2">
+            <a:schemeClr val="accent1"/>
+          </a:effectRef>
+          <a:fontRef idx="minor">
+            <a:schemeClr val="lt1"/>
+          </a:fontRef>
+        </p:style>
+        <p:txBody>
+          <a:bodyPr rtlCol="0" anchor="ctr"/>
+          <a:lstStyle/>
+          <a:p>
+            <a:pPr algn="ctr"/>
+          </a:p>
+        </p:txBody>
+      </p:sp>
+      <p:sp>
+        <p:nvSpPr>
+          <p:cNvPr id="36" name="TextBox 35"/>
+          <p:cNvSpPr txBox="1"/>
+          <p:nvPr/>
+        </p:nvSpPr>
+        <p:spPr>
+          <a:xfrm>
+            <a:off x="6428232" y="3959352"/>
+            <a:ext cx="914400" cy="182880"/>
+          </a:xfrm>
+          <a:prstGeom prst="rect">
+            <a:avLst/>
+          </a:prstGeom>
+          <a:noFill/>
+        </p:spPr>
+        <p:txBody>
+          <a:bodyPr wrap="square" anchor="t" lIns="0" rIns="0" tIns="0" bIns="0">
+            <a:spAutoFit/>
+          </a:bodyPr>
+          <a:lstStyle/>
+          <a:p>
+            <a:pPr algn="ctr">
+              <a:lnSpc>
+                <a:spcPct val="100000"/>
+              </a:lnSpc>
+              <a:spcBef>
+                <a:spcPts val="0"/>
+              </a:spcBef>
+              <a:spcAft>
+                <a:spcPts val="0"/>
+              </a:spcAft>
+            </a:pPr>
+            <a:r>
+              <a:rPr sz="650" b="0">
+                <a:solidFill>
+                  <a:srgbClr val="5A5757"/>
+                </a:solidFill>
+                <a:latin typeface="DM Sans"/>
+              </a:rPr>
+              <a:t>Датчики</a:t>
+            </a:r>
+          </a:p>
+        </p:txBody>
+      </p:sp>
+      <p:sp>
+        <p:nvSpPr>
+          <p:cNvPr id="37" name="TextBox 36"/>
+          <p:cNvSpPr txBox="1"/>
+          <p:nvPr/>
+        </p:nvSpPr>
+        <p:spPr>
+          <a:xfrm>
+            <a:off x="7223760" y="3163824"/>
+            <a:ext cx="1417320" cy="164592"/>
+          </a:xfrm>
+          <a:prstGeom prst="rect">
+            <a:avLst/>
+          </a:prstGeom>
+          <a:noFill/>
+        </p:spPr>
+        <p:txBody>
+          <a:bodyPr wrap="square" anchor="t" lIns="0" rIns="0" tIns="0" bIns="0">
+            <a:spAutoFit/>
+          </a:bodyPr>
+          <a:lstStyle/>
+          <a:p>
+            <a:pPr algn="ctr">
+              <a:lnSpc>
+                <a:spcPct val="100000"/>
+              </a:lnSpc>
+              <a:spcBef>
+                <a:spcPts val="0"/>
+              </a:spcBef>
+              <a:spcAft>
+                <a:spcPts val="0"/>
+              </a:spcAft>
+            </a:pPr>
+            <a:r>
+              <a:rPr sz="600" b="0">
+                <a:solidFill>
+                  <a:srgbClr val="5A5757"/>
+                </a:solidFill>
+                <a:latin typeface="DM Sans"/>
+              </a:rPr>
+              <a:t>RS-485 · Ethernet</a:t>
+            </a:r>
+          </a:p>
+        </p:txBody>
+      </p:sp>
+      <p:sp>
+        <p:nvSpPr>
+          <p:cNvPr id="38" name="Rounded Rectangle 37"/>
+          <p:cNvSpPr/>
+          <p:nvPr/>
+        </p:nvSpPr>
+        <p:spPr>
+          <a:xfrm>
+            <a:off x="7406640" y="3346704"/>
+            <a:ext cx="1051560" cy="438912"/>
+          </a:xfrm>
+          <a:prstGeom prst="roundRect">
+            <a:avLst>
+              <a:gd name="adj" fmla="val 18000"/>
+            </a:avLst>
+          </a:prstGeom>
+          <a:solidFill>
+            <a:srgbClr val="141212"/>
+          </a:solidFill>
+          <a:ln>
+            <a:noFill/>
+          </a:ln>
+          <a:effectLst/>
+        </p:spPr>
+        <p:style>
+          <a:lnRef idx="1">
+            <a:schemeClr val="accent1"/>
+          </a:lnRef>
+          <a:fillRef idx="3">
+            <a:schemeClr val="accent1"/>
+          </a:fillRef>
+          <a:effectRef idx="2">
+            <a:schemeClr val="accent1"/>
+          </a:effectRef>
+          <a:fontRef idx="minor">
+            <a:schemeClr val="lt1"/>
+          </a:fontRef>
+        </p:style>
+        <p:txBody>
+          <a:bodyPr rtlCol="0" anchor="ctr" wrap="square" lIns="36576" rIns="36576"/>
+          <a:lstStyle/>
+          <a:p>
+            <a:pPr algn="ctr">
+              <a:lnSpc>
+                <a:spcPct val="105000"/>
+              </a:lnSpc>
+              <a:spcBef>
+                <a:spcPts val="0"/>
+              </a:spcBef>
+              <a:spcAft>
+                <a:spcPts val="0"/>
+              </a:spcAft>
+            </a:pPr>
+            <a:r>
+              <a:rPr sz="1050" b="1">
+                <a:solidFill>
+                  <a:srgbClr val="FFFFFF"/>
+                </a:solidFill>
+                <a:latin typeface="DM Sans"/>
+              </a:rPr>
+              <a:t>RH2000</a:t>
+            </a:r>
+          </a:p>
+        </p:txBody>
+      </p:sp>
+      <p:sp>
+        <p:nvSpPr>
+          <p:cNvPr id="39" name="TextBox 38"/>
+          <p:cNvSpPr txBox="1"/>
+          <p:nvPr/>
+        </p:nvSpPr>
+        <p:spPr>
+          <a:xfrm>
+            <a:off x="7223760" y="3803904"/>
+            <a:ext cx="1417320" cy="164592"/>
+          </a:xfrm>
+          <a:prstGeom prst="rect">
+            <a:avLst/>
+          </a:prstGeom>
+          <a:noFill/>
+        </p:spPr>
+        <p:txBody>
+          <a:bodyPr wrap="square" anchor="t" lIns="0" rIns="0" tIns="0" bIns="0">
+            <a:spAutoFit/>
+          </a:bodyPr>
+          <a:lstStyle/>
+          <a:p>
+            <a:pPr algn="ctr">
+              <a:lnSpc>
+                <a:spcPct val="100000"/>
+              </a:lnSpc>
+              <a:spcBef>
+                <a:spcPts val="0"/>
+              </a:spcBef>
+              <a:spcAft>
+                <a:spcPts val="0"/>
+              </a:spcAft>
+            </a:pPr>
+            <a:r>
+              <a:rPr sz="600" b="0">
+                <a:solidFill>
+                  <a:srgbClr val="5A5757"/>
+                </a:solidFill>
+                <a:latin typeface="DM Sans"/>
+              </a:rPr>
+              <a:t>Шлюз</a:t>
+            </a:r>
+          </a:p>
+        </p:txBody>
+      </p:sp>
+      <p:cxnSp>
+        <p:nvCxnSpPr>
+          <p:cNvPr id="40" name="Connector 39"/>
+          <p:cNvCxnSpPr/>
+          <p:nvPr/>
+        </p:nvCxnSpPr>
+        <p:spPr>
+          <a:xfrm>
+            <a:off x="8458200" y="3566160"/>
+            <a:ext cx="1691640" cy="0"/>
+          </a:xfrm>
+          <a:prstGeom prst="line">
+            <a:avLst/>
+          </a:prstGeom>
+          <a:ln w="13970">
             <a:solidFill>
               <a:srgbClr val="B72E26"/>
             </a:solidFill>
@@ -6600,6 +7649,45 @@
           <a:effectLst/>
         </p:spPr>
         <p:style>
+          <a:lnRef idx="2">
+            <a:schemeClr val="accent1"/>
+          </a:lnRef>
+          <a:fillRef idx="0">
+            <a:schemeClr val="accent1"/>
+          </a:fillRef>
+          <a:effectRef idx="1">
+            <a:schemeClr val="accent1"/>
+          </a:effectRef>
+          <a:fontRef idx="minor">
+            <a:schemeClr val="tx1"/>
+          </a:fontRef>
+        </p:style>
+      </p:cxnSp>
+      <p:sp>
+        <p:nvSpPr>
+          <p:cNvPr id="41" name="Rounded Rectangle 40"/>
+          <p:cNvSpPr/>
+          <p:nvPr/>
+        </p:nvSpPr>
+        <p:spPr>
+          <a:xfrm>
+            <a:off x="10149840" y="3346704"/>
+            <a:ext cx="1051560" cy="438912"/>
+          </a:xfrm>
+          <a:prstGeom prst="roundRect">
+            <a:avLst>
+              <a:gd name="adj" fmla="val 18000"/>
+            </a:avLst>
+          </a:prstGeom>
+          <a:solidFill>
+            <a:srgbClr val="B72E26"/>
+          </a:solidFill>
+          <a:ln>
+            <a:noFill/>
+          </a:ln>
+          <a:effectLst/>
+        </p:spPr>
+        <p:style>
           <a:lnRef idx="1">
             <a:schemeClr val="accent1"/>
           </a:lnRef>
@@ -6614,64 +7702,64 @@
           </a:fontRef>
         </p:style>
         <p:txBody>
-          <a:bodyPr rtlCol="0" anchor="ctr" wrap="square" lIns="137160" rIns="137160"/>
+          <a:bodyPr rtlCol="0" anchor="ctr" wrap="square" lIns="36576" rIns="36576"/>
           <a:lstStyle/>
           <a:p>
             <a:pPr algn="ctr">
               <a:lnSpc>
-                <a:spcPct val="120000"/>
-              </a:lnSpc>
-              <a:spcBef>
-                <a:spcPts val="0"/>
-              </a:spcBef>
-              <a:spcAft>
-                <a:spcPts val="0"/>
-              </a:spcAft>
-            </a:pPr>
-            <a:r>
-              <a:rPr sz="1050" b="1">
-                <a:solidFill>
-                  <a:srgbClr val="8C1B13"/>
-                </a:solidFill>
-                <a:latin typeface="DM Sans"/>
-              </a:rPr>
-              <a:t>Схема из исходной презентации (слайды 12–14).</a:t>
+                <a:spcPct val="105000"/>
+              </a:lnSpc>
+              <a:spcBef>
+                <a:spcPts val="0"/>
+              </a:spcBef>
+              <a:spcAft>
+                <a:spcPts val="0"/>
+              </a:spcAft>
+            </a:pPr>
+            <a:r>
+              <a:rPr sz="850" b="1">
+                <a:solidFill>
+                  <a:srgbClr val="FFFFFF"/>
+                </a:solidFill>
+                <a:latin typeface="DM Sans"/>
+              </a:rPr>
+              <a:t>СЕРВЕР</a:t>
             </a:r>
           </a:p>
           <a:p>
             <a:pPr algn="ctr">
               <a:lnSpc>
-                <a:spcPct val="120000"/>
-              </a:lnSpc>
-              <a:spcBef>
-                <a:spcPts val="0"/>
-              </a:spcBef>
-              <a:spcAft>
-                <a:spcPts val="0"/>
-              </a:spcAft>
-            </a:pPr>
-            <a:r>
-              <a:rPr sz="1050" b="1">
-                <a:solidFill>
-                  <a:srgbClr val="8C1B13"/>
-                </a:solidFill>
-                <a:latin typeface="DM Sans"/>
-              </a:rPr>
-              <a:t>Логотипы завода-изготовителя на корпусах приборов удаляются.</a:t>
-            </a:r>
-          </a:p>
-        </p:txBody>
-      </p:sp>
-      <p:sp>
-        <p:nvSpPr>
-          <p:cNvPr id="17" name="TextBox 16"/>
+                <a:spcPct val="105000"/>
+              </a:lnSpc>
+              <a:spcBef>
+                <a:spcPts val="0"/>
+              </a:spcBef>
+              <a:spcAft>
+                <a:spcPts val="0"/>
+              </a:spcAft>
+            </a:pPr>
+            <a:r>
+              <a:rPr sz="850" b="1">
+                <a:solidFill>
+                  <a:srgbClr val="FFFFFF"/>
+                </a:solidFill>
+                <a:latin typeface="DM Sans"/>
+              </a:rPr>
+              <a:t>АСУ ТП</a:t>
+            </a:r>
+          </a:p>
+        </p:txBody>
+      </p:sp>
+      <p:sp>
+        <p:nvSpPr>
+          <p:cNvPr id="42" name="TextBox 41"/>
           <p:cNvSpPr txBox="1"/>
           <p:nvPr/>
         </p:nvSpPr>
         <p:spPr>
           <a:xfrm>
-            <a:off x="6492240" y="4297680"/>
-            <a:ext cx="4846320" cy="640080"/>
+            <a:off x="9875520" y="3803904"/>
+            <a:ext cx="1600200" cy="164592"/>
           </a:xfrm>
           <a:prstGeom prst="rect">
             <a:avLst/>
@@ -6684,19 +7772,64 @@
           </a:bodyPr>
           <a:lstStyle/>
           <a:p>
+            <a:pPr algn="ctr">
+              <a:lnSpc>
+                <a:spcPct val="100000"/>
+              </a:lnSpc>
+              <a:spcBef>
+                <a:spcPts val="0"/>
+              </a:spcBef>
+              <a:spcAft>
+                <a:spcPts val="0"/>
+              </a:spcAft>
+            </a:pPr>
+            <a:r>
+              <a:rPr sz="600" b="0">
+                <a:solidFill>
+                  <a:srgbClr val="5A5757"/>
+                </a:solidFill>
+                <a:latin typeface="DM Sans"/>
+              </a:rPr>
+              <a:t>Хранение и анализ</a:t>
+            </a:r>
+          </a:p>
+        </p:txBody>
+      </p:sp>
+      <p:sp>
+        <p:nvSpPr>
+          <p:cNvPr id="43" name="TextBox 42"/>
+          <p:cNvSpPr txBox="1"/>
+          <p:nvPr/>
+        </p:nvSpPr>
+        <p:spPr>
+          <a:xfrm>
+            <a:off x="6492240" y="4160520"/>
+            <a:ext cx="4846320" cy="384048"/>
+          </a:xfrm>
+          <a:prstGeom prst="rect">
+            <a:avLst/>
+          </a:prstGeom>
+          <a:noFill/>
+        </p:spPr>
+        <p:txBody>
+          <a:bodyPr wrap="square" anchor="t" lIns="0" rIns="0" tIns="0" bIns="0">
+            <a:spAutoFit/>
+          </a:bodyPr>
+          <a:lstStyle/>
+          <a:p>
             <a:pPr algn="l">
               <a:lnSpc>
-                <a:spcPct val="130000"/>
-              </a:lnSpc>
-              <a:spcBef>
-                <a:spcPts val="0"/>
-              </a:spcBef>
-              <a:spcAft>
-                <a:spcPts val="0"/>
-              </a:spcAft>
-            </a:pPr>
-            <a:r>
-              <a:rPr sz="1250" b="0">
+                <a:spcPct val="125000"/>
+              </a:lnSpc>
+              <a:spcBef>
+                <a:spcPts val="0"/>
+              </a:spcBef>
+              <a:spcAft>
+                <a:spcPts val="0"/>
+              </a:spcAft>
+            </a:pPr>
+            <a:r>
+              <a:rPr sz="1200" b="0">
                 <a:solidFill>
                   <a:srgbClr val="5A5757"/>
                 </a:solidFill>
@@ -6709,7 +7842,7 @@
       </p:sp>
       <p:sp>
         <p:nvSpPr>
-          <p:cNvPr id="18" name="TextBox 17"/>
+          <p:cNvPr id="44" name="TextBox 43"/>
           <p:cNvSpPr txBox="1"/>
           <p:nvPr/>
         </p:nvSpPr>
@@ -7313,7 +8446,123 @@
       </p:sp>
       <p:sp>
         <p:nvSpPr>
-          <p:cNvPr id="12" name="TextBox 11"/>
+          <p:cNvPr id="12" name="Oval 11"/>
+          <p:cNvSpPr/>
+          <p:nvPr/>
+        </p:nvSpPr>
+        <p:spPr>
+          <a:xfrm>
+            <a:off x="9619488" y="4453128"/>
+            <a:ext cx="512064" cy="512064"/>
+          </a:xfrm>
+          <a:prstGeom prst="ellipse">
+            <a:avLst/>
+          </a:prstGeom>
+          <a:noFill/>
+          <a:ln w="19050">
+            <a:solidFill>
+              <a:srgbClr val="FFFFFF"/>
+            </a:solidFill>
+          </a:ln>
+          <a:effectLst/>
+        </p:spPr>
+        <p:style>
+          <a:lnRef idx="1">
+            <a:schemeClr val="accent1"/>
+          </a:lnRef>
+          <a:fillRef idx="3">
+            <a:schemeClr val="accent1"/>
+          </a:fillRef>
+          <a:effectRef idx="2">
+            <a:schemeClr val="accent1"/>
+          </a:effectRef>
+          <a:fontRef idx="minor">
+            <a:schemeClr val="lt1"/>
+          </a:fontRef>
+        </p:style>
+        <p:txBody>
+          <a:bodyPr rtlCol="0" anchor="ctr"/>
+          <a:lstStyle/>
+          <a:p>
+            <a:pPr algn="ctr"/>
+          </a:p>
+        </p:txBody>
+      </p:sp>
+      <p:cxnSp>
+        <p:nvCxnSpPr>
+          <p:cNvPr id="13" name="Connector 12"/>
+          <p:cNvCxnSpPr/>
+          <p:nvPr/>
+        </p:nvCxnSpPr>
+        <p:spPr>
+          <a:xfrm>
+            <a:off x="9765792" y="4709160"/>
+            <a:ext cx="91440" cy="91440"/>
+          </a:xfrm>
+          <a:prstGeom prst="line">
+            <a:avLst/>
+          </a:prstGeom>
+          <a:ln w="27940">
+            <a:solidFill>
+              <a:srgbClr val="FFFFFF"/>
+            </a:solidFill>
+          </a:ln>
+          <a:effectLst/>
+        </p:spPr>
+        <p:style>
+          <a:lnRef idx="2">
+            <a:schemeClr val="accent1"/>
+          </a:lnRef>
+          <a:fillRef idx="0">
+            <a:schemeClr val="accent1"/>
+          </a:fillRef>
+          <a:effectRef idx="1">
+            <a:schemeClr val="accent1"/>
+          </a:effectRef>
+          <a:fontRef idx="minor">
+            <a:schemeClr val="tx1"/>
+          </a:fontRef>
+        </p:style>
+      </p:cxnSp>
+      <p:cxnSp>
+        <p:nvCxnSpPr>
+          <p:cNvPr id="14" name="Connector 13"/>
+          <p:cNvCxnSpPr/>
+          <p:nvPr/>
+        </p:nvCxnSpPr>
+        <p:spPr>
+          <a:xfrm flipV="1">
+            <a:off x="9857232" y="4599432"/>
+            <a:ext cx="155448" cy="201168"/>
+          </a:xfrm>
+          <a:prstGeom prst="line">
+            <a:avLst/>
+          </a:prstGeom>
+          <a:ln w="27940">
+            <a:solidFill>
+              <a:srgbClr val="FFFFFF"/>
+            </a:solidFill>
+          </a:ln>
+          <a:effectLst/>
+        </p:spPr>
+        <p:style>
+          <a:lnRef idx="2">
+            <a:schemeClr val="accent1"/>
+          </a:lnRef>
+          <a:fillRef idx="0">
+            <a:schemeClr val="accent1"/>
+          </a:fillRef>
+          <a:effectRef idx="1">
+            <a:schemeClr val="accent1"/>
+          </a:effectRef>
+          <a:fontRef idx="minor">
+            <a:schemeClr val="tx1"/>
+          </a:fontRef>
+        </p:style>
+      </p:cxnSp>
+      <p:sp>
+        <p:nvSpPr>
+          <p:cNvPr id="15" name="TextBox 14"/>
           <p:cNvSpPr txBox="1"/>
           <p:nvPr/>
         </p:nvSpPr>
@@ -7380,7 +8629,7 @@
       </p:sp>
       <p:sp>
         <p:nvSpPr>
-          <p:cNvPr id="13" name="TextBox 12"/>
+          <p:cNvPr id="16" name="TextBox 15"/>
           <p:cNvSpPr txBox="1"/>
           <p:nvPr/>
         </p:nvSpPr>
@@ -8035,9 +9284,693 @@
           </a:p>
         </p:txBody>
       </p:sp>
+      <p:sp>
+        <p:nvSpPr>
+          <p:cNvPr id="13" name="TextBox 12"/>
+          <p:cNvSpPr txBox="1"/>
+          <p:nvPr/>
+        </p:nvSpPr>
+        <p:spPr>
+          <a:xfrm>
+            <a:off x="8275320" y="1097280"/>
+            <a:ext cx="3337560" cy="457200"/>
+          </a:xfrm>
+          <a:prstGeom prst="rect">
+            <a:avLst/>
+          </a:prstGeom>
+          <a:noFill/>
+        </p:spPr>
+        <p:txBody>
+          <a:bodyPr wrap="square" anchor="t" lIns="0" rIns="0" tIns="0" bIns="0">
+            <a:spAutoFit/>
+          </a:bodyPr>
+          <a:lstStyle/>
+          <a:p>
+            <a:pPr algn="l">
+              <a:lnSpc>
+                <a:spcPct val="115000"/>
+              </a:lnSpc>
+              <a:spcBef>
+                <a:spcPts val="0"/>
+              </a:spcBef>
+              <a:spcAft>
+                <a:spcPts val="100"/>
+              </a:spcAft>
+            </a:pPr>
+            <a:r>
+              <a:rPr sz="1150" b="1">
+                <a:solidFill>
+                  <a:srgbClr val="FFFFFF"/>
+                </a:solidFill>
+                <a:latin typeface="DM Sans"/>
+              </a:rPr>
+              <a:t>Снижение внеплановых простоев,</a:t>
+            </a:r>
+          </a:p>
+          <a:p>
+            <a:pPr algn="l">
+              <a:lnSpc>
+                <a:spcPct val="115000"/>
+              </a:lnSpc>
+              <a:spcBef>
+                <a:spcPts val="0"/>
+              </a:spcBef>
+              <a:spcAft>
+                <a:spcPts val="0"/>
+              </a:spcAft>
+            </a:pPr>
+            <a:r>
+              <a:rPr sz="1150" b="1">
+                <a:solidFill>
+                  <a:srgbClr val="FFFFFF"/>
+                </a:solidFill>
+                <a:latin typeface="DM Sans"/>
+              </a:rPr>
+              <a:t>по направлениям внедрения</a:t>
+            </a:r>
+          </a:p>
+        </p:txBody>
+      </p:sp>
+      <p:cxnSp>
+        <p:nvCxnSpPr>
+          <p:cNvPr id="14" name="Connector 13"/>
+          <p:cNvCxnSpPr/>
+          <p:nvPr/>
+        </p:nvCxnSpPr>
+        <p:spPr>
+          <a:xfrm>
+            <a:off x="8275320" y="3136392"/>
+            <a:ext cx="3337560" cy="0"/>
+          </a:xfrm>
+          <a:prstGeom prst="line">
+            <a:avLst/>
+          </a:prstGeom>
+          <a:ln w="9525">
+            <a:solidFill>
+              <a:srgbClr val="8A8685"/>
+            </a:solidFill>
+          </a:ln>
+          <a:effectLst/>
+        </p:spPr>
+        <p:style>
+          <a:lnRef idx="2">
+            <a:schemeClr val="accent1"/>
+          </a:lnRef>
+          <a:fillRef idx="0">
+            <a:schemeClr val="accent1"/>
+          </a:fillRef>
+          <a:effectRef idx="1">
+            <a:schemeClr val="accent1"/>
+          </a:effectRef>
+          <a:fontRef idx="minor">
+            <a:schemeClr val="tx1"/>
+          </a:fontRef>
+        </p:style>
+      </p:cxnSp>
+      <p:sp>
+        <p:nvSpPr>
+          <p:cNvPr id="15" name="Rectangle 14"/>
+          <p:cNvSpPr/>
+          <p:nvPr/>
+        </p:nvSpPr>
+        <p:spPr>
+          <a:xfrm>
+            <a:off x="8483917" y="1947672"/>
+            <a:ext cx="417195" cy="1188720"/>
+          </a:xfrm>
+          <a:prstGeom prst="rect">
+            <a:avLst/>
+          </a:prstGeom>
+          <a:solidFill>
+            <a:srgbClr val="FFFFFF"/>
+          </a:solidFill>
+          <a:ln>
+            <a:noFill/>
+          </a:ln>
+          <a:effectLst/>
+        </p:spPr>
+        <p:style>
+          <a:lnRef idx="1">
+            <a:schemeClr val="accent1"/>
+          </a:lnRef>
+          <a:fillRef idx="3">
+            <a:schemeClr val="accent1"/>
+          </a:fillRef>
+          <a:effectRef idx="2">
+            <a:schemeClr val="accent1"/>
+          </a:effectRef>
+          <a:fontRef idx="minor">
+            <a:schemeClr val="lt1"/>
+          </a:fontRef>
+        </p:style>
+        <p:txBody>
+          <a:bodyPr rtlCol="0" anchor="ctr"/>
+          <a:lstStyle/>
+          <a:p>
+            <a:pPr algn="ctr"/>
+          </a:p>
+        </p:txBody>
+      </p:sp>
+      <p:sp>
+        <p:nvSpPr>
+          <p:cNvPr id="16" name="TextBox 15"/>
+          <p:cNvSpPr txBox="1"/>
+          <p:nvPr/>
+        </p:nvSpPr>
+        <p:spPr>
+          <a:xfrm>
+            <a:off x="8346757" y="1691640"/>
+            <a:ext cx="691515" cy="219456"/>
+          </a:xfrm>
+          <a:prstGeom prst="rect">
+            <a:avLst/>
+          </a:prstGeom>
+          <a:noFill/>
+        </p:spPr>
+        <p:txBody>
+          <a:bodyPr wrap="square" anchor="t" lIns="0" rIns="0" tIns="0" bIns="0">
+            <a:spAutoFit/>
+          </a:bodyPr>
+          <a:lstStyle/>
+          <a:p>
+            <a:pPr algn="ctr">
+              <a:lnSpc>
+                <a:spcPct val="100000"/>
+              </a:lnSpc>
+              <a:spcBef>
+                <a:spcPts val="0"/>
+              </a:spcBef>
+              <a:spcAft>
+                <a:spcPts val="0"/>
+              </a:spcAft>
+            </a:pPr>
+            <a:r>
+              <a:rPr sz="1100" b="1">
+                <a:solidFill>
+                  <a:srgbClr val="FFFFFF"/>
+                </a:solidFill>
+                <a:latin typeface="DM Sans"/>
+              </a:rPr>
+              <a:t>34%</a:t>
+            </a:r>
+          </a:p>
+        </p:txBody>
+      </p:sp>
+      <p:sp>
+        <p:nvSpPr>
+          <p:cNvPr id="17" name="TextBox 16"/>
+          <p:cNvSpPr txBox="1"/>
+          <p:nvPr/>
+        </p:nvSpPr>
+        <p:spPr>
+          <a:xfrm>
+            <a:off x="8275320" y="3182112"/>
+            <a:ext cx="834390" cy="274320"/>
+          </a:xfrm>
+          <a:prstGeom prst="rect">
+            <a:avLst/>
+          </a:prstGeom>
+          <a:noFill/>
+        </p:spPr>
+        <p:txBody>
+          <a:bodyPr wrap="square" anchor="t" lIns="0" rIns="0" tIns="0" bIns="0">
+            <a:spAutoFit/>
+          </a:bodyPr>
+          <a:lstStyle/>
+          <a:p>
+            <a:pPr algn="ctr">
+              <a:lnSpc>
+                <a:spcPct val="110000"/>
+              </a:lnSpc>
+              <a:spcBef>
+                <a:spcPts val="0"/>
+              </a:spcBef>
+              <a:spcAft>
+                <a:spcPts val="0"/>
+              </a:spcAft>
+            </a:pPr>
+            <a:r>
+              <a:rPr sz="800" b="1">
+                <a:solidFill>
+                  <a:srgbClr val="E8D8D6"/>
+                </a:solidFill>
+                <a:latin typeface="DM Sans"/>
+              </a:rPr>
+              <a:t>Добыча</a:t>
+            </a:r>
+          </a:p>
+        </p:txBody>
+      </p:sp>
+      <p:sp>
+        <p:nvSpPr>
+          <p:cNvPr id="18" name="Rectangle 17"/>
+          <p:cNvSpPr/>
+          <p:nvPr/>
+        </p:nvSpPr>
+        <p:spPr>
+          <a:xfrm>
+            <a:off x="9318307" y="2157447"/>
+            <a:ext cx="417195" cy="978945"/>
+          </a:xfrm>
+          <a:prstGeom prst="rect">
+            <a:avLst/>
+          </a:prstGeom>
+          <a:solidFill>
+            <a:srgbClr val="F3D6D3"/>
+          </a:solidFill>
+          <a:ln>
+            <a:noFill/>
+          </a:ln>
+          <a:effectLst/>
+        </p:spPr>
+        <p:style>
+          <a:lnRef idx="1">
+            <a:schemeClr val="accent1"/>
+          </a:lnRef>
+          <a:fillRef idx="3">
+            <a:schemeClr val="accent1"/>
+          </a:fillRef>
+          <a:effectRef idx="2">
+            <a:schemeClr val="accent1"/>
+          </a:effectRef>
+          <a:fontRef idx="minor">
+            <a:schemeClr val="lt1"/>
+          </a:fontRef>
+        </p:style>
+        <p:txBody>
+          <a:bodyPr rtlCol="0" anchor="ctr"/>
+          <a:lstStyle/>
+          <a:p>
+            <a:pPr algn="ctr"/>
+          </a:p>
+        </p:txBody>
+      </p:sp>
+      <p:sp>
+        <p:nvSpPr>
+          <p:cNvPr id="19" name="TextBox 18"/>
+          <p:cNvSpPr txBox="1"/>
+          <p:nvPr/>
+        </p:nvSpPr>
+        <p:spPr>
+          <a:xfrm>
+            <a:off x="9181147" y="1901415"/>
+            <a:ext cx="691515" cy="219456"/>
+          </a:xfrm>
+          <a:prstGeom prst="rect">
+            <a:avLst/>
+          </a:prstGeom>
+          <a:noFill/>
+        </p:spPr>
+        <p:txBody>
+          <a:bodyPr wrap="square" anchor="t" lIns="0" rIns="0" tIns="0" bIns="0">
+            <a:spAutoFit/>
+          </a:bodyPr>
+          <a:lstStyle/>
+          <a:p>
+            <a:pPr algn="ctr">
+              <a:lnSpc>
+                <a:spcPct val="100000"/>
+              </a:lnSpc>
+              <a:spcBef>
+                <a:spcPts val="0"/>
+              </a:spcBef>
+              <a:spcAft>
+                <a:spcPts val="0"/>
+              </a:spcAft>
+            </a:pPr>
+            <a:r>
+              <a:rPr sz="1100" b="1">
+                <a:solidFill>
+                  <a:srgbClr val="F3D6D3"/>
+                </a:solidFill>
+                <a:latin typeface="DM Sans"/>
+              </a:rPr>
+              <a:t>28%</a:t>
+            </a:r>
+          </a:p>
+        </p:txBody>
+      </p:sp>
+      <p:sp>
+        <p:nvSpPr>
+          <p:cNvPr id="20" name="TextBox 19"/>
+          <p:cNvSpPr txBox="1"/>
+          <p:nvPr/>
+        </p:nvSpPr>
+        <p:spPr>
+          <a:xfrm>
+            <a:off x="9109710" y="3182112"/>
+            <a:ext cx="834390" cy="274320"/>
+          </a:xfrm>
+          <a:prstGeom prst="rect">
+            <a:avLst/>
+          </a:prstGeom>
+          <a:noFill/>
+        </p:spPr>
+        <p:txBody>
+          <a:bodyPr wrap="square" anchor="t" lIns="0" rIns="0" tIns="0" bIns="0">
+            <a:spAutoFit/>
+          </a:bodyPr>
+          <a:lstStyle/>
+          <a:p>
+            <a:pPr algn="ctr">
+              <a:lnSpc>
+                <a:spcPct val="110000"/>
+              </a:lnSpc>
+              <a:spcBef>
+                <a:spcPts val="0"/>
+              </a:spcBef>
+              <a:spcAft>
+                <a:spcPts val="0"/>
+              </a:spcAft>
+            </a:pPr>
+            <a:r>
+              <a:rPr sz="800" b="1">
+                <a:solidFill>
+                  <a:srgbClr val="E8D8D6"/>
+                </a:solidFill>
+                <a:latin typeface="DM Sans"/>
+              </a:rPr>
+              <a:t>Металлургия</a:t>
+            </a:r>
+          </a:p>
+        </p:txBody>
+      </p:sp>
+      <p:sp>
+        <p:nvSpPr>
+          <p:cNvPr id="21" name="Rectangle 20"/>
+          <p:cNvSpPr/>
+          <p:nvPr/>
+        </p:nvSpPr>
+        <p:spPr>
+          <a:xfrm>
+            <a:off x="10152697" y="2367221"/>
+            <a:ext cx="417195" cy="769171"/>
+          </a:xfrm>
+          <a:prstGeom prst="rect">
+            <a:avLst/>
+          </a:prstGeom>
+          <a:solidFill>
+            <a:srgbClr val="F3D6D3"/>
+          </a:solidFill>
+          <a:ln>
+            <a:noFill/>
+          </a:ln>
+          <a:effectLst/>
+        </p:spPr>
+        <p:style>
+          <a:lnRef idx="1">
+            <a:schemeClr val="accent1"/>
+          </a:lnRef>
+          <a:fillRef idx="3">
+            <a:schemeClr val="accent1"/>
+          </a:fillRef>
+          <a:effectRef idx="2">
+            <a:schemeClr val="accent1"/>
+          </a:effectRef>
+          <a:fontRef idx="minor">
+            <a:schemeClr val="lt1"/>
+          </a:fontRef>
+        </p:style>
+        <p:txBody>
+          <a:bodyPr rtlCol="0" anchor="ctr"/>
+          <a:lstStyle/>
+          <a:p>
+            <a:pPr algn="ctr"/>
+          </a:p>
+        </p:txBody>
+      </p:sp>
+      <p:sp>
+        <p:nvSpPr>
+          <p:cNvPr id="22" name="TextBox 21"/>
+          <p:cNvSpPr txBox="1"/>
+          <p:nvPr/>
+        </p:nvSpPr>
+        <p:spPr>
+          <a:xfrm>
+            <a:off x="10015537" y="2111189"/>
+            <a:ext cx="691515" cy="219456"/>
+          </a:xfrm>
+          <a:prstGeom prst="rect">
+            <a:avLst/>
+          </a:prstGeom>
+          <a:noFill/>
+        </p:spPr>
+        <p:txBody>
+          <a:bodyPr wrap="square" anchor="t" lIns="0" rIns="0" tIns="0" bIns="0">
+            <a:spAutoFit/>
+          </a:bodyPr>
+          <a:lstStyle/>
+          <a:p>
+            <a:pPr algn="ctr">
+              <a:lnSpc>
+                <a:spcPct val="100000"/>
+              </a:lnSpc>
+              <a:spcBef>
+                <a:spcPts val="0"/>
+              </a:spcBef>
+              <a:spcAft>
+                <a:spcPts val="0"/>
+              </a:spcAft>
+            </a:pPr>
+            <a:r>
+              <a:rPr sz="1100" b="1">
+                <a:solidFill>
+                  <a:srgbClr val="F3D6D3"/>
+                </a:solidFill>
+                <a:latin typeface="DM Sans"/>
+              </a:rPr>
+              <a:t>22%</a:t>
+            </a:r>
+          </a:p>
+        </p:txBody>
+      </p:sp>
+      <p:sp>
+        <p:nvSpPr>
+          <p:cNvPr id="23" name="TextBox 22"/>
+          <p:cNvSpPr txBox="1"/>
+          <p:nvPr/>
+        </p:nvSpPr>
+        <p:spPr>
+          <a:xfrm>
+            <a:off x="9944100" y="3182112"/>
+            <a:ext cx="834390" cy="274320"/>
+          </a:xfrm>
+          <a:prstGeom prst="rect">
+            <a:avLst/>
+          </a:prstGeom>
+          <a:noFill/>
+        </p:spPr>
+        <p:txBody>
+          <a:bodyPr wrap="square" anchor="t" lIns="0" rIns="0" tIns="0" bIns="0">
+            <a:spAutoFit/>
+          </a:bodyPr>
+          <a:lstStyle/>
+          <a:p>
+            <a:pPr algn="ctr">
+              <a:lnSpc>
+                <a:spcPct val="110000"/>
+              </a:lnSpc>
+              <a:spcBef>
+                <a:spcPts val="0"/>
+              </a:spcBef>
+              <a:spcAft>
+                <a:spcPts val="0"/>
+              </a:spcAft>
+            </a:pPr>
+            <a:r>
+              <a:rPr sz="800" b="1">
+                <a:solidFill>
+                  <a:srgbClr val="E8D8D6"/>
+                </a:solidFill>
+                <a:latin typeface="DM Sans"/>
+              </a:rPr>
+              <a:t>Энергетика</a:t>
+            </a:r>
+          </a:p>
+        </p:txBody>
+      </p:sp>
+      <p:sp>
+        <p:nvSpPr>
+          <p:cNvPr id="24" name="Rectangle 23"/>
+          <p:cNvSpPr/>
+          <p:nvPr/>
+        </p:nvSpPr>
+        <p:spPr>
+          <a:xfrm>
+            <a:off x="10987087" y="2472108"/>
+            <a:ext cx="417195" cy="664284"/>
+          </a:xfrm>
+          <a:prstGeom prst="rect">
+            <a:avLst/>
+          </a:prstGeom>
+          <a:solidFill>
+            <a:srgbClr val="F3D6D3"/>
+          </a:solidFill>
+          <a:ln>
+            <a:noFill/>
+          </a:ln>
+          <a:effectLst/>
+        </p:spPr>
+        <p:style>
+          <a:lnRef idx="1">
+            <a:schemeClr val="accent1"/>
+          </a:lnRef>
+          <a:fillRef idx="3">
+            <a:schemeClr val="accent1"/>
+          </a:fillRef>
+          <a:effectRef idx="2">
+            <a:schemeClr val="accent1"/>
+          </a:effectRef>
+          <a:fontRef idx="minor">
+            <a:schemeClr val="lt1"/>
+          </a:fontRef>
+        </p:style>
+        <p:txBody>
+          <a:bodyPr rtlCol="0" anchor="ctr"/>
+          <a:lstStyle/>
+          <a:p>
+            <a:pPr algn="ctr"/>
+          </a:p>
+        </p:txBody>
+      </p:sp>
+      <p:sp>
+        <p:nvSpPr>
+          <p:cNvPr id="25" name="TextBox 24"/>
+          <p:cNvSpPr txBox="1"/>
+          <p:nvPr/>
+        </p:nvSpPr>
+        <p:spPr>
+          <a:xfrm>
+            <a:off x="10849927" y="2216076"/>
+            <a:ext cx="691515" cy="219456"/>
+          </a:xfrm>
+          <a:prstGeom prst="rect">
+            <a:avLst/>
+          </a:prstGeom>
+          <a:noFill/>
+        </p:spPr>
+        <p:txBody>
+          <a:bodyPr wrap="square" anchor="t" lIns="0" rIns="0" tIns="0" bIns="0">
+            <a:spAutoFit/>
+          </a:bodyPr>
+          <a:lstStyle/>
+          <a:p>
+            <a:pPr algn="ctr">
+              <a:lnSpc>
+                <a:spcPct val="100000"/>
+              </a:lnSpc>
+              <a:spcBef>
+                <a:spcPts val="0"/>
+              </a:spcBef>
+              <a:spcAft>
+                <a:spcPts val="0"/>
+              </a:spcAft>
+            </a:pPr>
+            <a:r>
+              <a:rPr sz="1100" b="1">
+                <a:solidFill>
+                  <a:srgbClr val="F3D6D3"/>
+                </a:solidFill>
+                <a:latin typeface="DM Sans"/>
+              </a:rPr>
+              <a:t>19%</a:t>
+            </a:r>
+          </a:p>
+        </p:txBody>
+      </p:sp>
+      <p:sp>
+        <p:nvSpPr>
+          <p:cNvPr id="26" name="TextBox 25"/>
+          <p:cNvSpPr txBox="1"/>
+          <p:nvPr/>
+        </p:nvSpPr>
+        <p:spPr>
+          <a:xfrm>
+            <a:off x="10778490" y="3182112"/>
+            <a:ext cx="834390" cy="274320"/>
+          </a:xfrm>
+          <a:prstGeom prst="rect">
+            <a:avLst/>
+          </a:prstGeom>
+          <a:noFill/>
+        </p:spPr>
+        <p:txBody>
+          <a:bodyPr wrap="square" anchor="t" lIns="0" rIns="0" tIns="0" bIns="0">
+            <a:spAutoFit/>
+          </a:bodyPr>
+          <a:lstStyle/>
+          <a:p>
+            <a:pPr algn="ctr">
+              <a:lnSpc>
+                <a:spcPct val="110000"/>
+              </a:lnSpc>
+              <a:spcBef>
+                <a:spcPts val="0"/>
+              </a:spcBef>
+              <a:spcAft>
+                <a:spcPts val="0"/>
+              </a:spcAft>
+            </a:pPr>
+            <a:r>
+              <a:rPr sz="800" b="1">
+                <a:solidFill>
+                  <a:srgbClr val="E8D8D6"/>
+                </a:solidFill>
+                <a:latin typeface="DM Sans"/>
+              </a:rPr>
+              <a:t>Цемент</a:t>
+            </a:r>
+          </a:p>
+        </p:txBody>
+      </p:sp>
+      <p:sp>
+        <p:nvSpPr>
+          <p:cNvPr id="27" name="TextBox 26"/>
+          <p:cNvSpPr txBox="1"/>
+          <p:nvPr/>
+        </p:nvSpPr>
+        <p:spPr>
+          <a:xfrm>
+            <a:off x="8275320" y="3611880"/>
+            <a:ext cx="3337560" cy="548640"/>
+          </a:xfrm>
+          <a:prstGeom prst="rect">
+            <a:avLst/>
+          </a:prstGeom>
+          <a:noFill/>
+        </p:spPr>
+        <p:txBody>
+          <a:bodyPr wrap="square" anchor="t" lIns="0" rIns="0" tIns="0" bIns="0">
+            <a:spAutoFit/>
+          </a:bodyPr>
+          <a:lstStyle/>
+          <a:p>
+            <a:pPr algn="l">
+              <a:lnSpc>
+                <a:spcPct val="130000"/>
+              </a:lnSpc>
+              <a:spcBef>
+                <a:spcPts val="0"/>
+              </a:spcBef>
+              <a:spcAft>
+                <a:spcPts val="0"/>
+              </a:spcAft>
+            </a:pPr>
+            <a:r>
+              <a:rPr sz="900" b="0">
+                <a:solidFill>
+                  <a:srgbClr val="C9AEAC"/>
+                </a:solidFill>
+                <a:latin typeface="DM Sans"/>
+              </a:rPr>
+              <a:t>Иллюстративные данные — приводятся как референс и уточняются по факту внедрения.</a:t>
+            </a:r>
+          </a:p>
+        </p:txBody>
+      </p:sp>
       <p:pic>
         <p:nvPicPr>
-          <p:cNvPr id="13" name="Picture 12" descr="algoritm-logo-white.png"/>
+          <p:cNvPr id="28" name="Picture 27" descr="algoritm-logo-white.png"/>
           <p:cNvPicPr>
             <a:picLocks noChangeAspect="1"/>
           </p:cNvPicPr>

</xml_diff>